<commit_message>
Regression deck: five-question in-class quiz
Co-Authored-By: Claude Opus 5.5 <noreply@anthropic.com>
Claude-Session: https://claude.ai/code/session_01TbrdxHn7W6FVXXnpqzNytd
</commit_message>
<xml_diff>
--- a/slides/01c_linear-regression_WT26-27.pptx
+++ b/slides/01c_linear-regression_WT26-27.pptx
@@ -2309,7 +2309,7 @@
           <a:lstStyle/>
           <a:p>
             <a:r>
-              <a:t>Answers: 1 C (the sum of squared residuals). 2 B (multicollinearity, VIF). 3 A (non-constant variance of the residuals). 4 C (an elasticity: 1 % more price, b % change in sales). Questions 1 to 3 adapted from the quantmethods exam bank; the written exam uses the same format.</a:t>
+              <a:t>Three minutes alone, then compare with your neighbour; reveal the answers one by one. Answers: 1 C (the sum of squared residuals). 2 B (log-log: an elasticity, 1 % higher price, 3.6 % fewer sales). 3 B (multicollinearity; VIF above 10 is a warning). 4 A (below 2: positive autocorrelation between neighbouring weeks, so the usual standard errors are too small; report HAC errors). 5 B (R-squared never falls when a variable is added; compare adjusted R-squared or test the coefficient). Questions 1 and 3 adapted from the quantmethods exam bank.</a:t>
             </a:r>
           </a:p>
         </p:txBody>
@@ -27556,7 +27556,7 @@
           <a:p>
             <a:r>
               <a:rPr sz="1600" lang="en-GB"/>
-              <a:t>Quick check: four questions</a:t>
+              <a:t>In-class quiz: five questions</a:t>
             </a:r>
           </a:p>
         </p:txBody>
@@ -27619,7 +27619,7 @@
         <p:spPr>
           <a:xfrm>
             <a:off x="457200" y="1234440"/>
-            <a:ext cx="8229600" cy="658368"/>
+            <a:ext cx="8229600" cy="585216"/>
           </a:xfrm>
           <a:prstGeom prst="rect">
             <a:avLst/>
@@ -27661,7 +27661,7 @@
         <p:spPr>
           <a:xfrm>
             <a:off x="457200" y="1234440"/>
-            <a:ext cx="64008" cy="658368"/>
+            <a:ext cx="64008" cy="585216"/>
           </a:xfrm>
           <a:prstGeom prst="rect">
             <a:avLst/>
@@ -27703,7 +27703,7 @@
         <p:spPr>
           <a:xfrm>
             <a:off x="658368" y="1234440"/>
-            <a:ext cx="7936992" cy="658368"/>
+            <a:ext cx="7955280" cy="585216"/>
           </a:xfrm>
           <a:prstGeom prst="rect">
             <a:avLst/>
@@ -27718,7 +27718,7 @@
           <a:p>
             <a:pPr algn="l">
               <a:spcAft>
-                <a:spcPts val="400"/>
+                <a:spcPts val="100"/>
               </a:spcAft>
             </a:pPr>
             <a:r>
@@ -27727,15 +27727,22 @@
                   <a:schemeClr val="tx2"/>
                 </a:solidFill>
               </a:rPr>
-              <a:t>1 OLS minimises </a:t>
-            </a:r>
+              <a:t>1 What does OLS minimise?</a:t>
+            </a:r>
+          </a:p>
+          <a:p>
+            <a:pPr algn="l">
+              <a:spcAft>
+                <a:spcPts val="100"/>
+              </a:spcAft>
+            </a:pPr>
             <a:r>
               <a:rPr sz="1200" b="0" lang="en-GB">
                 <a:solidFill>
                   <a:schemeClr val="tx1"/>
                 </a:solidFill>
               </a:rPr>
-              <a:t>A the sum of residuals · B the sum of absolute residuals · C the sum of squared residuals</a:t>
+              <a:t>A the sum of residuals     B the sum of absolute residuals     C the sum of squared residuals</a:t>
             </a:r>
           </a:p>
         </p:txBody>
@@ -27748,8 +27755,8 @@
         </p:nvSpPr>
         <p:spPr>
           <a:xfrm>
-            <a:off x="457200" y="1984248"/>
-            <a:ext cx="8229600" cy="658368"/>
+            <a:off x="457200" y="1892808"/>
+            <a:ext cx="8229600" cy="585216"/>
           </a:xfrm>
           <a:prstGeom prst="rect">
             <a:avLst/>
@@ -27790,8 +27797,8 @@
         </p:nvSpPr>
         <p:spPr>
           <a:xfrm>
-            <a:off x="457200" y="1984248"/>
-            <a:ext cx="64008" cy="658368"/>
+            <a:off x="457200" y="1892808"/>
+            <a:ext cx="64008" cy="585216"/>
           </a:xfrm>
           <a:prstGeom prst="rect">
             <a:avLst/>
@@ -27832,8 +27839,8 @@
         </p:nvSpPr>
         <p:spPr>
           <a:xfrm>
-            <a:off x="658368" y="1984248"/>
-            <a:ext cx="7936992" cy="658368"/>
+            <a:off x="658368" y="1892808"/>
+            <a:ext cx="7955280" cy="585216"/>
           </a:xfrm>
           <a:prstGeom prst="rect">
             <a:avLst/>
@@ -27848,7 +27855,7 @@
           <a:p>
             <a:pPr algn="l">
               <a:spcAft>
-                <a:spcPts val="400"/>
+                <a:spcPts val="100"/>
               </a:spcAft>
             </a:pPr>
             <a:r>
@@ -27857,15 +27864,22 @@
                   <a:schemeClr val="tx2"/>
                 </a:solidFill>
               </a:rPr>
-              <a:t>2 A VIF of 11 signals </a:t>
-            </a:r>
+              <a:t>2 In ln sales = a + b · ln price, b = −3.64 means …</a:t>
+            </a:r>
+          </a:p>
+          <a:p>
+            <a:pPr algn="l">
+              <a:spcAft>
+                <a:spcPts val="100"/>
+              </a:spcAft>
+            </a:pPr>
             <a:r>
               <a:rPr sz="1200" b="0" lang="en-GB">
                 <a:solidFill>
                   <a:schemeClr val="tx1"/>
                 </a:solidFill>
               </a:rPr>
-              <a:t>A autocorrelation · B multicollinearity · C heteroscedasticity</a:t>
+              <a:t>A 1 EUR more, 3.64 units fewer     B 1 % higher price, 3.6 % fewer sales     C 3.64 fewer per week</a:t>
             </a:r>
           </a:p>
         </p:txBody>
@@ -27878,8 +27892,8 @@
         </p:nvSpPr>
         <p:spPr>
           <a:xfrm>
-            <a:off x="457200" y="2734056"/>
-            <a:ext cx="8229600" cy="658368"/>
+            <a:off x="457200" y="2551176"/>
+            <a:ext cx="8229600" cy="585216"/>
           </a:xfrm>
           <a:prstGeom prst="rect">
             <a:avLst/>
@@ -27920,8 +27934,8 @@
         </p:nvSpPr>
         <p:spPr>
           <a:xfrm>
-            <a:off x="457200" y="2734056"/>
-            <a:ext cx="64008" cy="658368"/>
+            <a:off x="457200" y="2551176"/>
+            <a:ext cx="64008" cy="585216"/>
           </a:xfrm>
           <a:prstGeom prst="rect">
             <a:avLst/>
@@ -27962,8 +27976,8 @@
         </p:nvSpPr>
         <p:spPr>
           <a:xfrm>
-            <a:off x="658368" y="2734056"/>
-            <a:ext cx="7936992" cy="658368"/>
+            <a:off x="658368" y="2551176"/>
+            <a:ext cx="7955280" cy="585216"/>
           </a:xfrm>
           <a:prstGeom prst="rect">
             <a:avLst/>
@@ -27978,7 +27992,7 @@
           <a:p>
             <a:pPr algn="l">
               <a:spcAft>
-                <a:spcPts val="400"/>
+                <a:spcPts val="100"/>
               </a:spcAft>
             </a:pPr>
             <a:r>
@@ -27987,15 +28001,22 @@
                   <a:schemeClr val="tx2"/>
                 </a:solidFill>
               </a:rPr>
-              <a:t>3 Heteroscedasticity means </a:t>
-            </a:r>
+              <a:t>3 A VIF of 11 signals …</a:t>
+            </a:r>
+          </a:p>
+          <a:p>
+            <a:pPr algn="l">
+              <a:spcAft>
+                <a:spcPts val="100"/>
+              </a:spcAft>
+            </a:pPr>
             <a:r>
               <a:rPr sz="1200" b="0" lang="en-GB">
                 <a:solidFill>
                   <a:schemeClr val="tx1"/>
                 </a:solidFill>
               </a:rPr>
-              <a:t>A non-constant variance of the residuals · B correlated predictors · C non-normal sales</a:t>
+              <a:t>A autocorrelation     B multicollinearity     C heteroscedasticity</a:t>
             </a:r>
           </a:p>
         </p:txBody>
@@ -28008,8 +28029,8 @@
         </p:nvSpPr>
         <p:spPr>
           <a:xfrm>
-            <a:off x="457200" y="3483864"/>
-            <a:ext cx="8229600" cy="658368"/>
+            <a:off x="457200" y="3209544"/>
+            <a:ext cx="8229600" cy="585216"/>
           </a:xfrm>
           <a:prstGeom prst="rect">
             <a:avLst/>
@@ -28050,8 +28071,8 @@
         </p:nvSpPr>
         <p:spPr>
           <a:xfrm>
-            <a:off x="457200" y="3483864"/>
-            <a:ext cx="64008" cy="658368"/>
+            <a:off x="457200" y="3209544"/>
+            <a:ext cx="64008" cy="585216"/>
           </a:xfrm>
           <a:prstGeom prst="rect">
             <a:avLst/>
@@ -28092,8 +28113,8 @@
         </p:nvSpPr>
         <p:spPr>
           <a:xfrm>
-            <a:off x="658368" y="3483864"/>
-            <a:ext cx="7936992" cy="658368"/>
+            <a:off x="658368" y="3209544"/>
+            <a:ext cx="7955280" cy="585216"/>
           </a:xfrm>
           <a:prstGeom prst="rect">
             <a:avLst/>
@@ -28108,7 +28129,7 @@
           <a:p>
             <a:pPr algn="l">
               <a:spcAft>
-                <a:spcPts val="400"/>
+                <a:spcPts val="100"/>
               </a:spcAft>
             </a:pPr>
             <a:r>
@@ -28117,29 +28138,36 @@
                   <a:schemeClr val="tx2"/>
                 </a:solidFill>
               </a:rPr>
-              <a:t>4 In ln sales = a + b·ln price, b is </a:t>
-            </a:r>
+              <a:t>4 Weekly data, Durbin-Watson = 1.41. This suggests …</a:t>
+            </a:r>
+          </a:p>
+          <a:p>
+            <a:pPr algn="l">
+              <a:spcAft>
+                <a:spcPts val="100"/>
+              </a:spcAft>
+            </a:pPr>
             <a:r>
               <a:rPr sz="1200" b="0" lang="en-GB">
                 <a:solidFill>
                   <a:schemeClr val="tx1"/>
                 </a:solidFill>
               </a:rPr>
-              <a:t>A units per euro · B a percentage point change · C an elasticity</a:t>
-            </a:r>
-          </a:p>
-        </p:txBody>
-      </p:sp>
-      <p:sp>
-        <p:nvSpPr>
-          <p:cNvPr id="22" name="Quiz note box"/>
+              <a:t>A positive autocorrelation     B no problem     C unequal variance</a:t>
+            </a:r>
+          </a:p>
+        </p:txBody>
+      </p:sp>
+      <p:sp>
+        <p:nvSpPr>
+          <p:cNvPr id="22" name="Quiz row 5"/>
           <p:cNvSpPr/>
           <p:nvPr/>
         </p:nvSpPr>
         <p:spPr>
           <a:xfrm>
-            <a:off x="457200" y="4343400"/>
-            <a:ext cx="8229600" cy="502920"/>
+            <a:off x="457200" y="3867912"/>
+            <a:ext cx="8229600" cy="585216"/>
           </a:xfrm>
           <a:prstGeom prst="rect">
             <a:avLst/>
@@ -28172,9 +28200,146 @@
           <a:p/>
         </p:txBody>
       </p:sp>
+      <p:sp>
+        <p:nvSpPr>
+          <p:cNvPr id="23" name="Quiz bar 5"/>
+          <p:cNvSpPr/>
+          <p:nvPr/>
+        </p:nvSpPr>
+        <p:spPr>
+          <a:xfrm>
+            <a:off x="457200" y="3867912"/>
+            <a:ext cx="64008" cy="585216"/>
+          </a:xfrm>
+          <a:prstGeom prst="rect">
+            <a:avLst/>
+          </a:prstGeom>
+          <a:solidFill>
+            <a:schemeClr val="accent1"/>
+          </a:solidFill>
+          <a:ln>
+            <a:noFill/>
+          </a:ln>
+          <a:effectLst/>
+        </p:spPr>
+        <p:style>
+          <a:lnRef idx="1">
+            <a:schemeClr val="accent1"/>
+          </a:lnRef>
+          <a:fillRef idx="3">
+            <a:schemeClr val="accent1"/>
+          </a:fillRef>
+          <a:effectRef idx="2">
+            <a:schemeClr val="accent1"/>
+          </a:effectRef>
+          <a:fontRef idx="minor">
+            <a:schemeClr val="lt1"/>
+          </a:fontRef>
+        </p:style>
+        <p:txBody>
+          <a:bodyPr rtlCol="0" anchor="ctr"/>
+          <a:lstStyle/>
+          <a:p/>
+        </p:txBody>
+      </p:sp>
+      <p:sp>
+        <p:nvSpPr>
+          <p:cNvPr id="24" name="Quiz text 5"/>
+          <p:cNvSpPr txBox="1"/>
+          <p:nvPr/>
+        </p:nvSpPr>
+        <p:spPr>
+          <a:xfrm>
+            <a:off x="658368" y="3867912"/>
+            <a:ext cx="7955280" cy="585216"/>
+          </a:xfrm>
+          <a:prstGeom prst="rect">
+            <a:avLst/>
+          </a:prstGeom>
+          <a:noFill/>
+        </p:spPr>
+        <p:txBody>
+          <a:bodyPr wrap="square" lIns="0" rIns="0" tIns="0" bIns="0" anchor="ctr">
+            <a:noAutofit/>
+          </a:bodyPr>
+          <a:lstStyle/>
+          <a:p>
+            <a:pPr algn="l">
+              <a:spcAft>
+                <a:spcPts val="100"/>
+              </a:spcAft>
+            </a:pPr>
+            <a:r>
+              <a:rPr sz="1200" b="1" lang="en-GB">
+                <a:solidFill>
+                  <a:schemeClr val="tx2"/>
+                </a:solidFill>
+              </a:rPr>
+              <a:t>5 R² rises from 0.85 to 0.86 after adding a variable. This shows …</a:t>
+            </a:r>
+          </a:p>
+          <a:p>
+            <a:pPr algn="l">
+              <a:spcAft>
+                <a:spcPts val="100"/>
+              </a:spcAft>
+            </a:pPr>
+            <a:r>
+              <a:rPr sz="1200" b="0" lang="en-GB">
+                <a:solidFill>
+                  <a:schemeClr val="tx1"/>
+                </a:solidFill>
+              </a:rPr>
+              <a:t>A the variable matters     B nothing: R² never falls     C the model is causal</a:t>
+            </a:r>
+          </a:p>
+        </p:txBody>
+      </p:sp>
+      <p:sp>
+        <p:nvSpPr>
+          <p:cNvPr id="25" name="Quiz how box"/>
+          <p:cNvSpPr/>
+          <p:nvPr/>
+        </p:nvSpPr>
+        <p:spPr>
+          <a:xfrm>
+            <a:off x="457200" y="4572000"/>
+            <a:ext cx="8229600" cy="457200"/>
+          </a:xfrm>
+          <a:prstGeom prst="rect">
+            <a:avLst/>
+          </a:prstGeom>
+          <a:solidFill>
+            <a:schemeClr val="tx2"/>
+          </a:solidFill>
+          <a:ln>
+            <a:noFill/>
+          </a:ln>
+          <a:effectLst/>
+        </p:spPr>
+        <p:style>
+          <a:lnRef idx="1">
+            <a:schemeClr val="accent1"/>
+          </a:lnRef>
+          <a:fillRef idx="3">
+            <a:schemeClr val="accent1"/>
+          </a:fillRef>
+          <a:effectRef idx="2">
+            <a:schemeClr val="accent1"/>
+          </a:effectRef>
+          <a:fontRef idx="minor">
+            <a:schemeClr val="lt1"/>
+          </a:fontRef>
+        </p:style>
+        <p:txBody>
+          <a:bodyPr rtlCol="0" anchor="ctr"/>
+          <a:lstStyle/>
+          <a:p/>
+        </p:txBody>
+      </p:sp>
       <p:pic>
         <p:nvPicPr>
-          <p:cNvPr id="23" name="Icon Quiz note" descr=""/>
+          <p:cNvPr id="26" name="Icon Quiz how" descr=""/>
           <p:cNvPicPr>
             <a:picLocks noChangeAspect="1"/>
           </p:cNvPicPr>
@@ -28188,7 +28353,7 @@
         </p:blipFill>
         <p:spPr>
           <a:xfrm>
-            <a:off x="658368" y="4411980"/>
+            <a:off x="658368" y="4617720"/>
             <a:ext cx="365760" cy="365760"/>
           </a:xfrm>
           <a:prstGeom prst="rect">
@@ -28198,14 +28363,14 @@
       </p:pic>
       <p:sp>
         <p:nvSpPr>
-          <p:cNvPr id="24" name="Quiz note text"/>
+          <p:cNvPr id="27" name="Quiz how text"/>
           <p:cNvSpPr txBox="1"/>
           <p:nvPr/>
         </p:nvSpPr>
         <p:spPr>
           <a:xfrm>
-            <a:off x="1207008" y="4343400"/>
-            <a:ext cx="7315200" cy="502920"/>
+            <a:off x="1207008" y="4572000"/>
+            <a:ext cx="7315200" cy="457200"/>
           </a:xfrm>
           <a:prstGeom prst="rect">
             <a:avLst/>
@@ -28226,18 +28391,18 @@
             <a:r>
               <a:rPr sz="1200" b="1" lang="en-GB">
                 <a:solidFill>
-                  <a:schemeClr val="tx2"/>
-                </a:solidFill>
-              </a:rPr>
-              <a:t>Same format </a:t>
+                  <a:schemeClr val="bg1"/>
+                </a:solidFill>
+              </a:rPr>
+              <a:t>3 minutes alone, </a:t>
             </a:r>
             <a:r>
               <a:rPr sz="1200" b="0" lang="en-GB">
                 <a:solidFill>
-                  <a:schemeClr val="tx1"/>
-                </a:solidFill>
-              </a:rPr>
-              <a:t>as the online quiz after this session and the written exam.</a:t>
+                  <a:schemeClr val="bg1"/>
+                </a:solidFill>
+              </a:rPr>
+              <a:t>then compare with your neighbour. Same format as the online quiz and the exam.</a:t>
             </a:r>
           </a:p>
         </p:txBody>

</xml_diff>